<commit_message>
docs(ai-skill-studio): repair pixel clipping in customer-facing package
</commit_message>
<xml_diff>
--- a/docs/commercial/business-32-ai-skill-studio/customer-package/Business32_OnePage_Offer_Source.pptx
+++ b/docs/commercial/business-32-ai-skill-studio/customer-package/Business32_OnePage_Offer_Source.pptx
@@ -3228,8 +3228,8 @@
         </p:nvSpPr>
         <p:spPr>
           <a:xfrm>
-            <a:off x="457200" y="256032"/>
-            <a:ext cx="11338560" cy="457200"/>
+            <a:off x="457200" y="219456"/>
+            <a:ext cx="11338560" cy="411480"/>
           </a:xfrm>
           <a:prstGeom prst="rect">
             <a:avLst/>
@@ -3262,7 +3262,7 @@
         </p:nvSpPr>
         <p:spPr>
           <a:xfrm>
-            <a:off x="457200" y="566928"/>
+            <a:off x="457200" y="548640"/>
             <a:ext cx="11338560" cy="274320"/>
           </a:xfrm>
           <a:prstGeom prst="rect">
@@ -3297,7 +3297,7 @@
         <p:spPr>
           <a:xfrm>
             <a:off x="457200" y="868680"/>
-            <a:ext cx="11292840" cy="640080"/>
+            <a:ext cx="11292840" cy="548640"/>
           </a:xfrm>
           <a:prstGeom prst="rect">
             <a:avLst/>
@@ -3351,8 +3351,8 @@
         </p:nvSpPr>
         <p:spPr>
           <a:xfrm>
-            <a:off x="457200" y="1600200"/>
-            <a:ext cx="11292840" cy="640080"/>
+            <a:off x="457200" y="1490472"/>
+            <a:ext cx="11292840" cy="548640"/>
           </a:xfrm>
           <a:prstGeom prst="rect">
             <a:avLst/>
@@ -3406,8 +3406,8 @@
         </p:nvSpPr>
         <p:spPr>
           <a:xfrm>
-            <a:off x="457200" y="2331720"/>
-            <a:ext cx="11292840" cy="640080"/>
+            <a:off x="457200" y="2112264"/>
+            <a:ext cx="11292840" cy="548640"/>
           </a:xfrm>
           <a:prstGeom prst="rect">
             <a:avLst/>
@@ -3461,8 +3461,8 @@
         </p:nvSpPr>
         <p:spPr>
           <a:xfrm>
-            <a:off x="457200" y="3108960"/>
-            <a:ext cx="3657600" cy="1188720"/>
+            <a:off x="457200" y="2743200"/>
+            <a:ext cx="3657600" cy="1097280"/>
           </a:xfrm>
           <a:prstGeom prst="rect">
             <a:avLst/>
@@ -3505,7 +3505,7 @@
         </p:nvSpPr>
         <p:spPr>
           <a:xfrm>
-            <a:off x="640080" y="3246120"/>
+            <a:off x="640080" y="2871216"/>
             <a:ext cx="3291840" cy="365760"/>
           </a:xfrm>
           <a:prstGeom prst="rect">
@@ -3539,8 +3539,8 @@
         </p:nvSpPr>
         <p:spPr>
           <a:xfrm>
-            <a:off x="640080" y="3657600"/>
-            <a:ext cx="3291840" cy="548640"/>
+            <a:off x="640080" y="3246120"/>
+            <a:ext cx="3291840" cy="502920"/>
           </a:xfrm>
           <a:prstGeom prst="rect">
             <a:avLst/>
@@ -3573,8 +3573,8 @@
         </p:nvSpPr>
         <p:spPr>
           <a:xfrm>
-            <a:off x="4297680" y="3108960"/>
-            <a:ext cx="3657600" cy="1188720"/>
+            <a:off x="4297680" y="2743200"/>
+            <a:ext cx="3657600" cy="1097280"/>
           </a:xfrm>
           <a:prstGeom prst="rect">
             <a:avLst/>
@@ -3617,7 +3617,7 @@
         </p:nvSpPr>
         <p:spPr>
           <a:xfrm>
-            <a:off x="4480560" y="3246120"/>
+            <a:off x="4480560" y="2871216"/>
             <a:ext cx="3291840" cy="365760"/>
           </a:xfrm>
           <a:prstGeom prst="rect">
@@ -3651,8 +3651,8 @@
         </p:nvSpPr>
         <p:spPr>
           <a:xfrm>
-            <a:off x="4480560" y="3657600"/>
-            <a:ext cx="3291840" cy="548640"/>
+            <a:off x="4480560" y="3246120"/>
+            <a:ext cx="3291840" cy="502920"/>
           </a:xfrm>
           <a:prstGeom prst="rect">
             <a:avLst/>
@@ -3685,8 +3685,8 @@
         </p:nvSpPr>
         <p:spPr>
           <a:xfrm>
-            <a:off x="8138160" y="3108960"/>
-            <a:ext cx="3657600" cy="1188720"/>
+            <a:off x="8138160" y="2743200"/>
+            <a:ext cx="3657600" cy="1097280"/>
           </a:xfrm>
           <a:prstGeom prst="rect">
             <a:avLst/>
@@ -3729,7 +3729,7 @@
         </p:nvSpPr>
         <p:spPr>
           <a:xfrm>
-            <a:off x="8321040" y="3246120"/>
+            <a:off x="8321040" y="2871216"/>
             <a:ext cx="3291840" cy="365760"/>
           </a:xfrm>
           <a:prstGeom prst="rect">
@@ -3763,8 +3763,8 @@
         </p:nvSpPr>
         <p:spPr>
           <a:xfrm>
-            <a:off x="8321040" y="3657600"/>
-            <a:ext cx="3291840" cy="548640"/>
+            <a:off x="8321040" y="3246120"/>
+            <a:ext cx="3291840" cy="502920"/>
           </a:xfrm>
           <a:prstGeom prst="rect">
             <a:avLst/>
@@ -3797,8 +3797,8 @@
         </p:nvSpPr>
         <p:spPr>
           <a:xfrm>
-            <a:off x="457200" y="4526280"/>
-            <a:ext cx="11292840" cy="640080"/>
+            <a:off x="457200" y="3931920"/>
+            <a:ext cx="11292840" cy="548640"/>
           </a:xfrm>
           <a:prstGeom prst="rect">
             <a:avLst/>
@@ -3852,8 +3852,8 @@
         </p:nvSpPr>
         <p:spPr>
           <a:xfrm>
-            <a:off x="457200" y="5257800"/>
-            <a:ext cx="11292840" cy="640080"/>
+            <a:off x="457200" y="4553712"/>
+            <a:ext cx="11292840" cy="548640"/>
           </a:xfrm>
           <a:prstGeom prst="rect">
             <a:avLst/>
@@ -3907,8 +3907,8 @@
         </p:nvSpPr>
         <p:spPr>
           <a:xfrm>
-            <a:off x="457200" y="5989320"/>
-            <a:ext cx="11292840" cy="640080"/>
+            <a:off x="457200" y="5175504"/>
+            <a:ext cx="11292840" cy="548640"/>
           </a:xfrm>
           <a:prstGeom prst="rect">
             <a:avLst/>
@@ -3962,8 +3962,8 @@
         </p:nvSpPr>
         <p:spPr>
           <a:xfrm>
-            <a:off x="365760" y="6473952"/>
-            <a:ext cx="11430000" cy="320040"/>
+            <a:off x="457200" y="5943600"/>
+            <a:ext cx="11247120" cy="320040"/>
           </a:xfrm>
           <a:prstGeom prst="rect">
             <a:avLst/>
@@ -3971,7 +3971,7 @@
           <a:noFill/>
         </p:spPr>
         <p:txBody>
-          <a:bodyPr wrap="square">
+          <a:bodyPr wrap="none">
             <a:spAutoFit/>
           </a:bodyPr>
           <a:lstStyle/>

</xml_diff>